<commit_message>
Add crash-circumstance strata (manner, weather, rurality, alcohol) + JSR PNG/TIFF package
- build_fars_strata.py: new dims manner (MAN_COLL), weather (WEATHER),
  rururb (RUR_URB), alcohol (any driver with police-reported drinking)
- analyze_us_strata.py: fit primary model per stratum -> us_crashcontext_response.csv
- figures_us.py: fig_us_crashcontext forest plot
- make_manuscript.py: new Results paragraph + Table 6 + Figure 9 (Japan
  figures renumbered 10-11, sensitivity table -> 7), methods/limitations/
  discussion updated, STROBE locations updated
- make_jsr_submission.py: cover letter highlights new mechanism evidence;
  zip now includes per-figure PNG+TIFF and tables.docx

Co-Authored-By: Tatsuki Onishi <bougtoir@gmail.com>
</commit_message>
<xml_diff>
--- a/output/manuscript/figures.pptx
+++ b/output/manuscript/figures.pptx
@@ -15,6 +15,7 @@
     <p:sldId id="263" r:id="rId14"/>
     <p:sldId id="264" r:id="rId15"/>
     <p:sldId id="265" r:id="rId16"/>
+    <p:sldId id="266" r:id="rId17"/>
   </p:sldIdLst>
   <p:sldSz cx="12191695" cy="6858000" type="screen4x3"/>
   <p:notesSz cx="6858000" cy="9144000"/>
@@ -3228,6 +3229,106 @@
       </p:sp>
       <p:pic>
         <p:nvPicPr>
+          <p:cNvPr id="3" name="Picture 2" descr="jp_fig2_anomaly_exposure_response.png"/>
+          <p:cNvPicPr>
+            <a:picLocks noChangeAspect="1"/>
+          </p:cNvPicPr>
+          <p:nvPr/>
+        </p:nvPicPr>
+        <p:blipFill>
+          <a:blip r:embed="rId2"/>
+          <a:stretch>
+            <a:fillRect/>
+          </a:stretch>
+        </p:blipFill>
+        <p:spPr>
+          <a:xfrm>
+            <a:off x="2286000" y="914400"/>
+            <a:ext cx="6139646" cy="4389120"/>
+          </a:xfrm>
+          <a:prstGeom prst="rect">
+            <a:avLst/>
+          </a:prstGeom>
+        </p:spPr>
+      </p:pic>
+      <p:sp>
+        <p:nvSpPr>
+          <p:cNvPr id="4" name="TextBox 3"/>
+          <p:cNvSpPr txBox="1"/>
+          <p:nvPr/>
+        </p:nvSpPr>
+        <p:spPr>
+          <a:xfrm>
+            <a:off x="457200" y="5486400"/>
+            <a:ext cx="11247120" cy="1188720"/>
+          </a:xfrm>
+          <a:prstGeom prst="rect">
+            <a:avLst/>
+          </a:prstGeom>
+          <a:noFill/>
+        </p:spPr>
+        <p:txBody>
+          <a:bodyPr wrap="square">
+            <a:spAutoFit/>
+          </a:bodyPr>
+          <a:lstStyle/>
+          <a:p>
+            <a:r>
+              <a:rPr sz="1200"/>
+              <a:t>Japan temperature-anomaly exposure-response (2019-2024). The estimate is imprecise: the confidence band is wide and includes the null throughout.</a:t>
+            </a:r>
+          </a:p>
+        </p:txBody>
+      </p:sp>
+    </p:spTree>
+  </p:cSld>
+  <p:clrMapOvr>
+    <a:masterClrMapping/>
+  </p:clrMapOvr>
+</p:sld>
+</file>
+
+<file path=ppt/slides/slide11.xml><?xml version="1.0" encoding="utf-8"?>
+<p:sld xmlns:a="http://schemas.openxmlformats.org/drawingml/2006/main" xmlns:p="http://schemas.openxmlformats.org/presentationml/2006/main" xmlns:r="http://schemas.openxmlformats.org/officeDocument/2006/relationships">
+  <p:cSld>
+    <p:spTree>
+      <p:nvGrpSpPr>
+        <p:cNvPr id="1" name=""/>
+        <p:cNvGrpSpPr/>
+        <p:nvPr/>
+      </p:nvGrpSpPr>
+      <p:grpSpPr/>
+      <p:sp>
+        <p:nvSpPr>
+          <p:cNvPr id="2" name="TextBox 1"/>
+          <p:cNvSpPr txBox="1"/>
+          <p:nvPr/>
+        </p:nvSpPr>
+        <p:spPr>
+          <a:xfrm>
+            <a:off x="457200" y="182880"/>
+            <a:ext cx="11247120" cy="548640"/>
+          </a:xfrm>
+          <a:prstGeom prst="rect">
+            <a:avLst/>
+          </a:prstGeom>
+          <a:noFill/>
+        </p:spPr>
+        <p:txBody>
+          <a:bodyPr wrap="none">
+            <a:spAutoFit/>
+          </a:bodyPr>
+          <a:lstStyle/>
+          <a:p>
+            <a:r>
+              <a:rPr sz="2200" b="1"/>
+              <a:t>Figure 11</a:t>
+            </a:r>
+          </a:p>
+        </p:txBody>
+      </p:sp>
+      <p:pic>
+        <p:nvPicPr>
           <p:cNvPr id="3" name="Picture 2" descr="cross_fig_us_vs_japan_sameday.png"/>
           <p:cNvPicPr>
             <a:picLocks noChangeAspect="1"/>
@@ -4028,7 +4129,7 @@
       </p:sp>
       <p:pic>
         <p:nvPicPr>
-          <p:cNvPr id="3" name="Picture 2" descr="jp_fig2_anomaly_exposure_response.png"/>
+          <p:cNvPr id="3" name="Picture 2" descr="fig_us_crashcontext.png"/>
           <p:cNvPicPr>
             <a:picLocks noChangeAspect="1"/>
           </p:cNvPicPr>
@@ -4043,7 +4144,7 @@
         <p:spPr>
           <a:xfrm>
             <a:off x="2286000" y="914400"/>
-            <a:ext cx="6139646" cy="4389120"/>
+            <a:ext cx="7076634" cy="4389120"/>
           </a:xfrm>
           <a:prstGeom prst="rect">
             <a:avLst/>
@@ -4074,7 +4175,7 @@
           <a:p>
             <a:r>
               <a:rPr sz="1200"/>
-              <a:t>Japan temperature-anomaly exposure-response (2019-2024). The estimate is imprecise: the confidence band is wide and includes the null throughout.</a:t>
+              <a:t>United States same-day rate ratio of crash death for a +9 °C anomaly by crash circumstances: manner of collision, weather condition, rural/urban land use and police-reported driver drinking. The excess is present for clear or cloudy days, is larger for single-vehicle (not a collision with a motor vehicle in transport) than multi-vehicle crashes, and is similar regardless of reported driver drinking—patterns consistent with a direct heat contribution rather than adverse-weather surface conditions or a purely behavioural pathway. These subgroup analyses are exploratory and are not adjusted for multiple comparisons.</a:t>
             </a:r>
           </a:p>
         </p:txBody>

</xml_diff>

<commit_message>
Add Japan accident-type and prefecture-density strata (transit hypothesis test)
- build_jp_strata.py: deaths per prefecture-day by NPA accident type
  (single-vehicle / vehicle-vehicle / vehicle-pedestrian)
- build_jp_density.py: 2020 census population density per prefecture,
  median split as a public-transport availability proxy
- analyze_japan.py: refit anomaly model within each stratum ->
  jp_strata_response.csv; all CIs wide, ordering mirrors US
- fig_jp_strata (Fig 12), Table 8, results + discussion text

Co-Authored-By: Tatsuki Onishi <bougtoir@gmail.com>
</commit_message>
<xml_diff>
--- a/output/manuscript/figures.pptx
+++ b/output/manuscript/figures.pptx
@@ -16,6 +16,7 @@
     <p:sldId id="264" r:id="rId15"/>
     <p:sldId id="265" r:id="rId16"/>
     <p:sldId id="266" r:id="rId17"/>
+    <p:sldId id="267" r:id="rId18"/>
   </p:sldIdLst>
   <p:sldSz cx="12191695" cy="6858000" type="screen4x3"/>
   <p:notesSz cx="6858000" cy="9144000"/>
@@ -3376,6 +3377,106 @@
             <a:r>
               <a:rPr sz="1200"/>
               <a:t>Same-day rate ratio of traffic-crash deaths for a +9 °C anomaly, United States versus Japan. The US shows a precise acute effect; the Japanese estimate is underpowered. This comparison is exploratory and is not adjusted for multiple comparisons.</a:t>
+            </a:r>
+          </a:p>
+        </p:txBody>
+      </p:sp>
+    </p:spTree>
+  </p:cSld>
+  <p:clrMapOvr>
+    <a:masterClrMapping/>
+  </p:clrMapOvr>
+</p:sld>
+</file>
+
+<file path=ppt/slides/slide12.xml><?xml version="1.0" encoding="utf-8"?>
+<p:sld xmlns:a="http://schemas.openxmlformats.org/drawingml/2006/main" xmlns:p="http://schemas.openxmlformats.org/presentationml/2006/main" xmlns:r="http://schemas.openxmlformats.org/officeDocument/2006/relationships">
+  <p:cSld>
+    <p:spTree>
+      <p:nvGrpSpPr>
+        <p:cNvPr id="1" name=""/>
+        <p:cNvGrpSpPr/>
+        <p:nvPr/>
+      </p:nvGrpSpPr>
+      <p:grpSpPr/>
+      <p:sp>
+        <p:nvSpPr>
+          <p:cNvPr id="2" name="TextBox 1"/>
+          <p:cNvSpPr txBox="1"/>
+          <p:nvPr/>
+        </p:nvSpPr>
+        <p:spPr>
+          <a:xfrm>
+            <a:off x="457200" y="182880"/>
+            <a:ext cx="11247120" cy="548640"/>
+          </a:xfrm>
+          <a:prstGeom prst="rect">
+            <a:avLst/>
+          </a:prstGeom>
+          <a:noFill/>
+        </p:spPr>
+        <p:txBody>
+          <a:bodyPr wrap="none">
+            <a:spAutoFit/>
+          </a:bodyPr>
+          <a:lstStyle/>
+          <a:p>
+            <a:r>
+              <a:rPr sz="2200" b="1"/>
+              <a:t>Figure 12</a:t>
+            </a:r>
+          </a:p>
+        </p:txBody>
+      </p:sp>
+      <p:pic>
+        <p:nvPicPr>
+          <p:cNvPr id="3" name="Picture 2" descr="fig_jp_strata.png"/>
+          <p:cNvPicPr>
+            <a:picLocks noChangeAspect="1"/>
+          </p:cNvPicPr>
+          <p:nvPr/>
+        </p:nvPicPr>
+        <p:blipFill>
+          <a:blip r:embed="rId2"/>
+          <a:stretch>
+            <a:fillRect/>
+          </a:stretch>
+        </p:blipFill>
+        <p:spPr>
+          <a:xfrm>
+            <a:off x="2286000" y="914400"/>
+            <a:ext cx="7581208" cy="4389120"/>
+          </a:xfrm>
+          <a:prstGeom prst="rect">
+            <a:avLst/>
+          </a:prstGeom>
+        </p:spPr>
+      </p:pic>
+      <p:sp>
+        <p:nvSpPr>
+          <p:cNvPr id="4" name="TextBox 3"/>
+          <p:cNvSpPr txBox="1"/>
+          <p:nvPr/>
+        </p:nvSpPr>
+        <p:spPr>
+          <a:xfrm>
+            <a:off x="457200" y="5486400"/>
+            <a:ext cx="11247120" cy="1188720"/>
+          </a:xfrm>
+          <a:prstGeom prst="rect">
+            <a:avLst/>
+          </a:prstGeom>
+          <a:noFill/>
+        </p:spPr>
+        <p:txBody>
+          <a:bodyPr wrap="square">
+            <a:spAutoFit/>
+          </a:bodyPr>
+          <a:lstStyle/>
+          <a:p>
+            <a:r>
+              <a:rPr sz="1200"/>
+              <a:t>Japan same-day rate ratio of crash death for a +9 °C anomaly by accident type (single-vehicle, vehicle-vehicle, vehicle-pedestrian) and by prefecture population density (a proxy for public-transport availability, split at the median). All confidence intervals are wide and include the null; these stratified analyses are exploratory and are not adjusted for multiple comparisons.</a:t>
             </a:r>
           </a:p>
         </p:txBody>

</xml_diff>